<commit_message>
Updated ppt and word
</commit_message>
<xml_diff>
--- a/FakeScope_Presentation.pptx
+++ b/FakeScope_Presentation.pptx
@@ -6490,7 +6490,7 @@
                 <a:ea typeface="Trebuchet MS" pitchFamily="34" charset="-122"/>
                 <a:cs typeface="Trebuchet MS" pitchFamily="34" charset="-120"/>
               </a:rPr>
-              <a:t>XX.X%</a:t>
+              <a:t>88.68%</a:t>
             </a:r>
             <a:endParaRPr lang="en-US" sz="2800" dirty="0"/>
           </a:p>
@@ -6625,7 +6625,7 @@
                 <a:ea typeface="Trebuchet MS" pitchFamily="34" charset="-122"/>
                 <a:cs typeface="Trebuchet MS" pitchFamily="34" charset="-120"/>
               </a:rPr>
-              <a:t>XX.X%</a:t>
+              <a:t>85.05%</a:t>
             </a:r>
             <a:endParaRPr lang="en-US" sz="2800" dirty="0"/>
           </a:p>
@@ -6760,7 +6760,7 @@
                 <a:ea typeface="Trebuchet MS" pitchFamily="34" charset="-122"/>
                 <a:cs typeface="Trebuchet MS" pitchFamily="34" charset="-120"/>
               </a:rPr>
-              <a:t>XX.X%</a:t>
+              <a:t>79.92%</a:t>
             </a:r>
             <a:endParaRPr lang="en-US" sz="2800" dirty="0"/>
           </a:p>
@@ -6895,7 +6895,7 @@
                 <a:ea typeface="Trebuchet MS" pitchFamily="34" charset="-122"/>
                 <a:cs typeface="Trebuchet MS" pitchFamily="34" charset="-120"/>
               </a:rPr>
-              <a:t>XX.X%</a:t>
+              <a:t>82.41%</a:t>
             </a:r>
             <a:endParaRPr lang="en-US" sz="2800" dirty="0"/>
           </a:p>
@@ -7030,7 +7030,7 @@
                 <a:ea typeface="Trebuchet MS" pitchFamily="34" charset="-122"/>
                 <a:cs typeface="Trebuchet MS" pitchFamily="34" charset="-120"/>
               </a:rPr>
-              <a:t>X.XXX</a:t>
+              <a:t>0.9399</a:t>
             </a:r>
             <a:endParaRPr lang="en-US" sz="2800" dirty="0"/>
           </a:p>
@@ -7172,7 +7172,7 @@
                 <a:ea typeface="Trebuchet MS" pitchFamily="34" charset="-122"/>
                 <a:cs typeface="Trebuchet MS" pitchFamily="34" charset="-120"/>
               </a:rPr>
-              <a:t>X.XXX  ±  X.XXX</a:t>
+              <a:t>0.9399  ±  0.0024</a:t>
             </a:r>
             <a:endParaRPr lang="en-US" sz="2200" dirty="0"/>
           </a:p>
@@ -7211,7 +7211,7 @@
                 <a:ea typeface="Consolas" pitchFamily="34" charset="-122"/>
                 <a:cs typeface="Consolas" pitchFamily="34" charset="-120"/>
               </a:rPr>
-              <a:t>▸  Replace XX.X% values with actual results from Colab notebook before submission</a:t>
+              <a:t>▸  Validated on held-out 20% test set  ·  5-Fold CV AUC: 0.9399 ± 0.0024</a:t>
             </a:r>
             <a:endParaRPr lang="en-US" sz="1000" dirty="0"/>
           </a:p>

</xml_diff>